<commit_message>
chore: clean repo for GitHub — remove dev junk, fix showcase manifest
- Remove copy_project_to_clipboard.sh (local LLM helper, not for repo)
- Regenerate showcase/manifest.json with portable relative paths
- Drop ephemeral slide_pngs and absolute /tmp paths from manifest
- Extend .gitignore for .skills and dev helper script
- Delete stale out/phase8-from-worktree.patch locally
</commit_message>
<xml_diff>
--- a/showcase/presentations/01_obzor_nalogov_RB.pptx
+++ b/showcase/presentations/01_obzor_nalogov_RB.pptx
@@ -3326,7 +3326,7 @@
               </a:defRPr>
             </a:pPr>
             <a:r>
-              <a:t>06.06.2026</a:t>
+              <a:t>07.06.2026</a:t>
             </a:r>
           </a:p>
         </p:txBody>
@@ -4396,7 +4396,7 @@
       </p:sp>
       <p:pic>
         <p:nvPicPr>
-          <p:cNvPr id="5" name="Picture 4" descr="pres_slide_9a260dfbc6_0_г_минск_лидер_по_объ_му_начислений.png"/>
+          <p:cNvPr id="5" name="Picture 4" descr="pres_slide_cf1bd8de73_0_г_минск_лидер_по_объ_му_начислений.png"/>
           <p:cNvPicPr>
             <a:picLocks noChangeAspect="1"/>
           </p:cNvPicPr>
@@ -5017,7 +5017,7 @@
       </p:sp>
       <p:pic>
         <p:nvPicPr>
-          <p:cNvPr id="5" name="Picture 4" descr="pres_slide_9a260dfbc6_1_гомельская_область_лидер_по_задолженност.png"/>
+          <p:cNvPr id="5" name="Picture 4" descr="pres_slide_cf1bd8de73_1_гомельская_область_лидер_по_задолженност.png"/>
           <p:cNvPicPr>
             <a:picLocks noChangeAspect="1"/>
           </p:cNvPicPr>

</xml_diff>